<commit_message>
feat(slides): decks C1/C4/C10 mejorados (portada Fondo1, contraste, logos) + versiones enriquecidas con laminas de datos reales + PDFs (3 niveles)
</commit_message>
<xml_diff>
--- a/clase_01_estrategia_transformacion/slides/slides_clase01_avanzado.pptx
+++ b/clase_01_estrategia_transformacion/slides/slides_clase01_avanzado.pptx
@@ -3094,389 +3094,40 @@
         <p:nvPr/>
       </p:nvGrpSpPr>
       <p:grpSpPr/>
-      <p:sp>
-        <p:nvSpPr>
-          <p:cNvPr id="2" name="Rectangle 1"/>
-          <p:cNvSpPr/>
-          <p:nvPr/>
-        </p:nvSpPr>
-        <p:spPr>
-          <a:xfrm>
-            <a:off x="0" y="0"/>
-            <a:ext cx="12188952" cy="6858000"/>
-          </a:xfrm>
-          <a:prstGeom prst="rect">
-            <a:avLst/>
-          </a:prstGeom>
-          <a:solidFill>
-            <a:srgbClr val="962D37"/>
-          </a:solidFill>
-          <a:ln>
-            <a:noFill/>
-          </a:ln>
-        </p:spPr>
-        <p:style>
-          <a:lnRef idx="1">
-            <a:schemeClr val="accent1"/>
-          </a:lnRef>
-          <a:fillRef idx="3">
-            <a:schemeClr val="accent1"/>
-          </a:fillRef>
-          <a:effectRef idx="2">
-            <a:schemeClr val="accent1"/>
-          </a:effectRef>
-          <a:fontRef idx="minor">
-            <a:schemeClr val="lt1"/>
-          </a:fontRef>
-        </p:style>
-        <p:txBody>
-          <a:bodyPr rtlCol="0" anchor="ctr"/>
-          <a:lstStyle/>
-          <a:p>
-            <a:pPr algn="ctr"/>
-          </a:p>
-        </p:txBody>
-      </p:sp>
-      <p:sp>
-        <p:nvSpPr>
-          <p:cNvPr id="3" name="Rectangle 2"/>
-          <p:cNvSpPr/>
-          <p:nvPr/>
-        </p:nvSpPr>
-        <p:spPr>
-          <a:xfrm>
-            <a:off x="8074152" y="0"/>
-            <a:ext cx="4114800" cy="6858000"/>
-          </a:xfrm>
-          <a:prstGeom prst="rect">
-            <a:avLst/>
-          </a:prstGeom>
-          <a:solidFill>
-            <a:srgbClr val="782323"/>
-          </a:solidFill>
-          <a:ln>
-            <a:noFill/>
-          </a:ln>
-        </p:spPr>
-        <p:style>
-          <a:lnRef idx="1">
-            <a:schemeClr val="accent1"/>
-          </a:lnRef>
-          <a:fillRef idx="3">
-            <a:schemeClr val="accent1"/>
-          </a:fillRef>
-          <a:effectRef idx="2">
-            <a:schemeClr val="accent1"/>
-          </a:effectRef>
-          <a:fontRef idx="minor">
-            <a:schemeClr val="lt1"/>
-          </a:fontRef>
-        </p:style>
-        <p:txBody>
-          <a:bodyPr rtlCol="0" anchor="ctr"/>
-          <a:lstStyle/>
-          <a:p>
-            <a:pPr algn="ctr"/>
-          </a:p>
-        </p:txBody>
-      </p:sp>
-      <p:sp>
-        <p:nvSpPr>
-          <p:cNvPr id="4" name="Rectangle 3"/>
-          <p:cNvSpPr/>
-          <p:nvPr/>
-        </p:nvSpPr>
-        <p:spPr>
-          <a:xfrm>
-            <a:off x="0" y="0"/>
-            <a:ext cx="12188952" cy="91440"/>
-          </a:xfrm>
-          <a:prstGeom prst="rect">
-            <a:avLst/>
-          </a:prstGeom>
-          <a:solidFill>
-            <a:srgbClr val="D4A017"/>
-          </a:solidFill>
-          <a:ln>
-            <a:noFill/>
-          </a:ln>
-        </p:spPr>
-        <p:style>
-          <a:lnRef idx="1">
-            <a:schemeClr val="accent1"/>
-          </a:lnRef>
-          <a:fillRef idx="3">
-            <a:schemeClr val="accent1"/>
-          </a:fillRef>
-          <a:effectRef idx="2">
-            <a:schemeClr val="accent1"/>
-          </a:effectRef>
-          <a:fontRef idx="minor">
-            <a:schemeClr val="lt1"/>
-          </a:fontRef>
-        </p:style>
-        <p:txBody>
-          <a:bodyPr rtlCol="0" anchor="ctr"/>
-          <a:lstStyle/>
-          <a:p>
-            <a:pPr algn="ctr"/>
-          </a:p>
-        </p:txBody>
-      </p:sp>
-      <p:sp>
-        <p:nvSpPr>
-          <p:cNvPr id="5" name="Rectangle 4"/>
-          <p:cNvSpPr/>
-          <p:nvPr/>
-        </p:nvSpPr>
-        <p:spPr>
-          <a:xfrm>
-            <a:off x="0" y="6766560"/>
-            <a:ext cx="12188952" cy="91440"/>
-          </a:xfrm>
-          <a:prstGeom prst="rect">
-            <a:avLst/>
-          </a:prstGeom>
-          <a:solidFill>
-            <a:srgbClr val="D4A017"/>
-          </a:solidFill>
-          <a:ln>
-            <a:noFill/>
-          </a:ln>
-        </p:spPr>
-        <p:style>
-          <a:lnRef idx="1">
-            <a:schemeClr val="accent1"/>
-          </a:lnRef>
-          <a:fillRef idx="3">
-            <a:schemeClr val="accent1"/>
-          </a:fillRef>
-          <a:effectRef idx="2">
-            <a:schemeClr val="accent1"/>
-          </a:effectRef>
-          <a:fontRef idx="minor">
-            <a:schemeClr val="lt1"/>
-          </a:fontRef>
-        </p:style>
-        <p:txBody>
-          <a:bodyPr rtlCol="0" anchor="ctr"/>
-          <a:lstStyle/>
-          <a:p>
-            <a:pPr algn="ctr"/>
-          </a:p>
-        </p:txBody>
-      </p:sp>
-      <p:sp>
-        <p:nvSpPr>
-          <p:cNvPr id="6" name="Rectangle 5"/>
-          <p:cNvSpPr/>
-          <p:nvPr/>
-        </p:nvSpPr>
-        <p:spPr>
-          <a:xfrm>
-            <a:off x="0" y="5806440"/>
-            <a:ext cx="12188952" cy="960120"/>
-          </a:xfrm>
-          <a:prstGeom prst="rect">
-            <a:avLst/>
-          </a:prstGeom>
-          <a:solidFill>
-            <a:srgbClr val="000000"/>
-          </a:solidFill>
-          <a:ln>
-            <a:noFill/>
-          </a:ln>
-        </p:spPr>
-        <p:style>
-          <a:lnRef idx="1">
-            <a:schemeClr val="accent1"/>
-          </a:lnRef>
-          <a:fillRef idx="3">
-            <a:schemeClr val="accent1"/>
-          </a:fillRef>
-          <a:effectRef idx="2">
-            <a:schemeClr val="accent1"/>
-          </a:effectRef>
-          <a:fontRef idx="minor">
-            <a:schemeClr val="lt1"/>
-          </a:fontRef>
-        </p:style>
-        <p:txBody>
-          <a:bodyPr rtlCol="0" anchor="ctr"/>
-          <a:lstStyle/>
-          <a:p>
-            <a:pPr algn="ctr"/>
-          </a:p>
-        </p:txBody>
-      </p:sp>
-      <p:sp>
-        <p:nvSpPr>
-          <p:cNvPr id="7" name="Rectangle 6"/>
-          <p:cNvSpPr/>
-          <p:nvPr/>
-        </p:nvSpPr>
-        <p:spPr>
-          <a:xfrm>
-            <a:off x="0" y="5806440"/>
-            <a:ext cx="12188952" cy="960120"/>
-          </a:xfrm>
-          <a:prstGeom prst="rect">
-            <a:avLst/>
-          </a:prstGeom>
-          <a:solidFill>
-            <a:srgbClr val="87415F"/>
-          </a:solidFill>
-          <a:ln>
-            <a:noFill/>
-          </a:ln>
-        </p:spPr>
-        <p:style>
-          <a:lnRef idx="1">
-            <a:schemeClr val="accent1"/>
-          </a:lnRef>
-          <a:fillRef idx="3">
-            <a:schemeClr val="accent1"/>
-          </a:fillRef>
-          <a:effectRef idx="2">
-            <a:schemeClr val="accent1"/>
-          </a:effectRef>
-          <a:fontRef idx="minor">
-            <a:schemeClr val="lt1"/>
-          </a:fontRef>
-        </p:style>
-        <p:txBody>
-          <a:bodyPr rtlCol="0" anchor="ctr"/>
-          <a:lstStyle/>
-          <a:p>
-            <a:pPr algn="ctr"/>
-          </a:p>
-        </p:txBody>
-      </p:sp>
       <p:pic>
         <p:nvPicPr>
-          <p:cNvPr id="8" name="Picture 7" descr="logo_utn_frch_negro.png"/>
+          <p:cNvPr id="2" name="Picture 1" descr="cover_bg.png"/>
           <p:cNvPicPr>
             <a:picLocks noChangeAspect="1"/>
           </p:cNvPicPr>
           <p:nvPr/>
         </p:nvPicPr>
         <p:blipFill>
-          <a:blip r:embed="rId2"/>
+          <a:blip r:embed="rId5"/>
           <a:stretch>
             <a:fillRect/>
           </a:stretch>
         </p:blipFill>
         <p:spPr>
           <a:xfrm>
-            <a:off x="365760" y="155448"/>
-            <a:ext cx="1366857" cy="731520"/>
+            <a:off x="0" y="0"/>
+            <a:ext cx="12188952" cy="6858000"/>
           </a:xfrm>
           <a:prstGeom prst="rect">
             <a:avLst/>
           </a:prstGeom>
         </p:spPr>
       </p:pic>
-      <p:pic>
-        <p:nvPicPr>
-          <p:cNvPr id="9" name="Picture 8" descr="logo_pesqueros_full.png"/>
-          <p:cNvPicPr>
-            <a:picLocks noChangeAspect="1"/>
-          </p:cNvPicPr>
-          <p:nvPr/>
-        </p:nvPicPr>
-        <p:blipFill>
-          <a:blip r:embed="rId3"/>
-          <a:stretch>
-            <a:fillRect/>
-          </a:stretch>
-        </p:blipFill>
-        <p:spPr>
-          <a:xfrm>
-            <a:off x="8897112" y="228600"/>
-            <a:ext cx="1981200" cy="594360"/>
-          </a:xfrm>
-          <a:prstGeom prst="rect">
-            <a:avLst/>
-          </a:prstGeom>
-        </p:spPr>
-      </p:pic>
-      <p:pic>
-        <p:nvPicPr>
-          <p:cNvPr id="10" name="Picture 9" descr="logo_ariel_symbol.png"/>
-          <p:cNvPicPr>
-            <a:picLocks noChangeAspect="1"/>
-          </p:cNvPicPr>
-          <p:nvPr/>
-        </p:nvPicPr>
-        <p:blipFill>
-          <a:blip r:embed="rId4"/>
-          <a:stretch>
-            <a:fillRect/>
-          </a:stretch>
-        </p:blipFill>
-        <p:spPr>
-          <a:xfrm>
-            <a:off x="11091672" y="228600"/>
-            <a:ext cx="1981200" cy="594360"/>
-          </a:xfrm>
-          <a:prstGeom prst="rect">
-            <a:avLst/>
-          </a:prstGeom>
-        </p:spPr>
-      </p:pic>
-      <p:sp>
-        <p:nvSpPr>
-          <p:cNvPr id="11" name="Rectangle 10"/>
-          <p:cNvSpPr/>
-          <p:nvPr/>
-        </p:nvSpPr>
-        <p:spPr>
-          <a:xfrm>
-            <a:off x="365760" y="1078992"/>
-            <a:ext cx="11457432" cy="32004"/>
-          </a:xfrm>
-          <a:prstGeom prst="rect">
-            <a:avLst/>
-          </a:prstGeom>
-          <a:solidFill>
-            <a:srgbClr val="0099CC"/>
-          </a:solidFill>
-          <a:ln>
-            <a:noFill/>
-          </a:ln>
-        </p:spPr>
-        <p:style>
-          <a:lnRef idx="1">
-            <a:schemeClr val="accent1"/>
-          </a:lnRef>
-          <a:fillRef idx="3">
-            <a:schemeClr val="accent1"/>
-          </a:fillRef>
-          <a:effectRef idx="2">
-            <a:schemeClr val="accent1"/>
-          </a:effectRef>
-          <a:fontRef idx="minor">
-            <a:schemeClr val="lt1"/>
-          </a:fontRef>
-        </p:style>
-        <p:txBody>
-          <a:bodyPr rtlCol="0" anchor="ctr"/>
-          <a:lstStyle/>
-          <a:p>
-            <a:pPr algn="ctr"/>
-          </a:p>
-        </p:txBody>
-      </p:sp>
-      <p:sp>
-        <p:nvSpPr>
-          <p:cNvPr id="12" name="TextBox 11"/>
+      <p:sp>
+        <p:nvSpPr>
+          <p:cNvPr id="3" name="TextBox 2"/>
           <p:cNvSpPr txBox="1"/>
           <p:nvPr/>
         </p:nvSpPr>
         <p:spPr>
           <a:xfrm>
-            <a:off x="411480" y="1234440"/>
-            <a:ext cx="3657600" cy="384048"/>
+            <a:off x="566928" y="4041648"/>
+            <a:ext cx="8229600" cy="411480"/>
           </a:xfrm>
           <a:prstGeom prst="rect">
             <a:avLst/>
@@ -3489,13 +3140,12 @@
           </a:bodyPr>
           <a:lstStyle/>
           <a:p>
-            <a:pPr algn="l"/>
-            <a:r>
-              <a:rPr sz="1200" b="1" i="0">
-                <a:solidFill>
-                  <a:srgbClr val="0099CC"/>
-                </a:solidFill>
-                <a:latin typeface="Calibri"/>
+            <a:r>
+              <a:rPr sz="1500" b="1">
+                <a:solidFill>
+                  <a:srgbClr val="E7C14B"/>
+                </a:solidFill>
+                <a:latin typeface="Segoe UI"/>
               </a:rPr>
               <a:t>CLASE 1</a:t>
             </a:r>
@@ -3504,14 +3154,14 @@
       </p:sp>
       <p:sp>
         <p:nvSpPr>
-          <p:cNvPr id="13" name="TextBox 12"/>
+          <p:cNvPr id="4" name="TextBox 3"/>
           <p:cNvSpPr txBox="1"/>
           <p:nvPr/>
         </p:nvSpPr>
         <p:spPr>
           <a:xfrm>
-            <a:off x="411480" y="1600200"/>
-            <a:ext cx="7434072" cy="2286000"/>
+            <a:off x="548640" y="4389120"/>
+            <a:ext cx="9509760" cy="1371600"/>
           </a:xfrm>
           <a:prstGeom prst="rect">
             <a:avLst/>
@@ -3524,13 +3174,12 @@
           </a:bodyPr>
           <a:lstStyle/>
           <a:p>
-            <a:pPr algn="l"/>
-            <a:r>
-              <a:rPr sz="3400" b="1" i="0">
+            <a:r>
+              <a:rPr sz="3400" b="1">
                 <a:solidFill>
                   <a:srgbClr val="FFFFFF"/>
                 </a:solidFill>
-                <a:latin typeface="Calibri"/>
+                <a:latin typeface="Segoe UI"/>
               </a:rPr>
               <a:t>Estrategia y Transformación Digital</a:t>
             </a:r>
@@ -3539,14 +3188,14 @@
       </p:sp>
       <p:sp>
         <p:nvSpPr>
-          <p:cNvPr id="14" name="TextBox 13"/>
+          <p:cNvPr id="5" name="TextBox 4"/>
           <p:cNvSpPr txBox="1"/>
           <p:nvPr/>
         </p:nvSpPr>
         <p:spPr>
           <a:xfrm>
-            <a:off x="411480" y="3794760"/>
-            <a:ext cx="7434072" cy="685800"/>
+            <a:off x="566928" y="5623560"/>
+            <a:ext cx="9509760" cy="457200"/>
           </a:xfrm>
           <a:prstGeom prst="rect">
             <a:avLst/>
@@ -3559,13 +3208,12 @@
           </a:bodyPr>
           <a:lstStyle/>
           <a:p>
-            <a:pPr algn="l"/>
-            <a:r>
-              <a:rPr sz="1700" b="0" i="0">
-                <a:solidFill>
-                  <a:srgbClr val="0099CC"/>
-                </a:solidFill>
-                <a:latin typeface="Calibri"/>
+            <a:r>
+              <a:rPr sz="1550" b="0">
+                <a:solidFill>
+                  <a:srgbClr val="DDE9F0"/>
+                </a:solidFill>
+                <a:latin typeface="Segoe UI"/>
               </a:rPr>
               <a:t>Clase 1 · Nivel AVANZADO — De entender a liderar</a:t>
             </a:r>
@@ -3574,14 +3222,14 @@
       </p:sp>
       <p:sp>
         <p:nvSpPr>
-          <p:cNvPr id="15" name="TextBox 14"/>
+          <p:cNvPr id="6" name="TextBox 5"/>
           <p:cNvSpPr txBox="1"/>
           <p:nvPr/>
         </p:nvSpPr>
         <p:spPr>
           <a:xfrm>
-            <a:off x="8348472" y="2286000"/>
-            <a:ext cx="3474720" cy="914400"/>
+            <a:off x="566928" y="6108192"/>
+            <a:ext cx="9509760" cy="365760"/>
           </a:xfrm>
           <a:prstGeom prst="rect">
             <a:avLst/>
@@ -3594,29 +3242,28 @@
           </a:bodyPr>
           <a:lstStyle/>
           <a:p>
-            <a:pPr algn="ctr"/>
-            <a:r>
-              <a:rPr sz="2200" b="0" i="1">
-                <a:solidFill>
-                  <a:srgbClr val="B4D2F0"/>
-                </a:solidFill>
-                <a:latin typeface="Calibri"/>
+            <a:r>
+              <a:rPr sz="1350" b="1">
+                <a:solidFill>
+                  <a:srgbClr val="FFFFFF"/>
+                </a:solidFill>
+                <a:latin typeface="Segoe UI"/>
               </a:rPr>
-              <a:t>IA · Pesca · Datos</a:t>
-            </a:r>
-          </a:p>
-        </p:txBody>
-      </p:sp>
-      <p:sp>
-        <p:nvSpPr>
-          <p:cNvPr id="16" name="TextBox 15"/>
+              <a:t>Docentes: Ariel Giamportone, Soraya Corvalán</a:t>
+            </a:r>
+          </a:p>
+        </p:txBody>
+      </p:sp>
+      <p:sp>
+        <p:nvSpPr>
+          <p:cNvPr id="7" name="TextBox 6"/>
           <p:cNvSpPr txBox="1"/>
           <p:nvPr/>
         </p:nvSpPr>
         <p:spPr>
           <a:xfrm>
-            <a:off x="8348472" y="3108960"/>
-            <a:ext cx="3474720" cy="548640"/>
+            <a:off x="566928" y="6455664"/>
+            <a:ext cx="10607040" cy="320040"/>
           </a:xfrm>
           <a:prstGeom prst="rect">
             <a:avLst/>
@@ -3629,83 +3276,12 @@
           </a:bodyPr>
           <a:lstStyle/>
           <a:p>
-            <a:pPr algn="ctr"/>
-            <a:r>
-              <a:rPr sz="1300" b="0" i="0">
-                <a:solidFill>
-                  <a:srgbClr val="96BEE6"/>
-                </a:solidFill>
-                <a:latin typeface="Calibri"/>
-              </a:rPr>
-              <a:t>UTN FRCh + PesquerosEnIA</a:t>
-            </a:r>
-          </a:p>
-        </p:txBody>
-      </p:sp>
-      <p:sp>
-        <p:nvSpPr>
-          <p:cNvPr id="17" name="TextBox 16"/>
-          <p:cNvSpPr txBox="1"/>
-          <p:nvPr/>
-        </p:nvSpPr>
-        <p:spPr>
-          <a:xfrm>
-            <a:off x="411480" y="5897880"/>
-            <a:ext cx="8229600" cy="438912"/>
-          </a:xfrm>
-          <a:prstGeom prst="rect">
-            <a:avLst/>
-          </a:prstGeom>
-          <a:noFill/>
-        </p:spPr>
-        <p:txBody>
-          <a:bodyPr wrap="square">
-            <a:spAutoFit/>
-          </a:bodyPr>
-          <a:lstStyle/>
-          <a:p>
-            <a:pPr algn="l"/>
-            <a:r>
-              <a:rPr sz="1400" b="1" i="0">
-                <a:solidFill>
-                  <a:srgbClr val="FFFFFF"/>
-                </a:solidFill>
-                <a:latin typeface="Calibri"/>
-              </a:rPr>
-              <a:t>Docentes: ['Ariel Giamportone', 'Soraya Corvalán']</a:t>
-            </a:r>
-          </a:p>
-        </p:txBody>
-      </p:sp>
-      <p:sp>
-        <p:nvSpPr>
-          <p:cNvPr id="18" name="TextBox 17"/>
-          <p:cNvSpPr txBox="1"/>
-          <p:nvPr/>
-        </p:nvSpPr>
-        <p:spPr>
-          <a:xfrm>
-            <a:off x="411480" y="6309360"/>
-            <a:ext cx="11365992" cy="411480"/>
-          </a:xfrm>
-          <a:prstGeom prst="rect">
-            <a:avLst/>
-          </a:prstGeom>
-          <a:noFill/>
-        </p:spPr>
-        <p:txBody>
-          <a:bodyPr wrap="square">
-            <a:spAutoFit/>
-          </a:bodyPr>
-          <a:lstStyle/>
-          <a:p>
-            <a:pPr algn="l"/>
-            <a:r>
-              <a:rPr sz="1000" b="0" i="0">
-                <a:solidFill>
-                  <a:srgbClr val="BEDCFA"/>
-                </a:solidFill>
-                <a:latin typeface="Calibri"/>
+            <a:r>
+              <a:rPr sz="1000" b="0">
+                <a:solidFill>
+                  <a:srgbClr val="DDE9F0"/>
+                </a:solidFill>
+                <a:latin typeface="Segoe UI"/>
               </a:rPr>
               <a:t>Inteligencia Artificial Aplicada a la Produccion Pesquera  |  UTN FRCh  |  2026</a:t>
             </a:r>
@@ -3885,7 +3461,7 @@
             <a:r>
               <a:rPr sz="1300" b="1" i="0">
                 <a:solidFill>
-                  <a:srgbClr val="0099CC"/>
+                  <a:srgbClr val="E7C14B"/>
                 </a:solidFill>
                 <a:latin typeface="Calibri"/>
               </a:rPr>
@@ -4587,7 +4163,7 @@
             <a:r>
               <a:rPr sz="1000" b="0" i="0">
                 <a:solidFill>
-                  <a:srgbClr val="0099CC"/>
+                  <a:srgbClr val="FFFFFF"/>
                 </a:solidFill>
                 <a:latin typeface="Calibri"/>
               </a:rPr>
@@ -4769,7 +4345,7 @@
             <a:r>
               <a:rPr sz="1100" b="1" i="0">
                 <a:solidFill>
-                  <a:srgbClr val="0099CC"/>
+                  <a:srgbClr val="E7C14B"/>
                 </a:solidFill>
                 <a:latin typeface="Calibri"/>
               </a:rPr>
@@ -5627,7 +5203,7 @@
             <a:r>
               <a:rPr sz="1000" b="0" i="0">
                 <a:solidFill>
-                  <a:srgbClr val="0099CC"/>
+                  <a:srgbClr val="FFFFFF"/>
                 </a:solidFill>
                 <a:latin typeface="Calibri"/>
               </a:rPr>
@@ -5809,7 +5385,7 @@
             <a:r>
               <a:rPr sz="1100" b="1" i="0">
                 <a:solidFill>
-                  <a:srgbClr val="0099CC"/>
+                  <a:srgbClr val="E7C14B"/>
                 </a:solidFill>
                 <a:latin typeface="Calibri"/>
               </a:rPr>
@@ -6045,7 +5621,7 @@
             <a:r>
               <a:rPr sz="1000" b="0" i="0">
                 <a:solidFill>
-                  <a:srgbClr val="0099CC"/>
+                  <a:srgbClr val="FFFFFF"/>
                 </a:solidFill>
                 <a:latin typeface="Calibri"/>
               </a:rPr>
@@ -6227,7 +5803,7 @@
             <a:r>
               <a:rPr sz="1100" b="1" i="0">
                 <a:solidFill>
-                  <a:srgbClr val="0099CC"/>
+                  <a:srgbClr val="E7C14B"/>
                 </a:solidFill>
                 <a:latin typeface="Calibri"/>
               </a:rPr>
@@ -6463,7 +6039,7 @@
             <a:r>
               <a:rPr sz="1000" b="0" i="0">
                 <a:solidFill>
-                  <a:srgbClr val="0099CC"/>
+                  <a:srgbClr val="FFFFFF"/>
                 </a:solidFill>
                 <a:latin typeface="Calibri"/>
               </a:rPr>
@@ -6645,7 +6221,7 @@
             <a:r>
               <a:rPr sz="1100" b="1" i="0">
                 <a:solidFill>
-                  <a:srgbClr val="0099CC"/>
+                  <a:srgbClr val="E7C14B"/>
                 </a:solidFill>
                 <a:latin typeface="Calibri"/>
               </a:rPr>
@@ -6881,7 +6457,7 @@
             <a:r>
               <a:rPr sz="1000" b="0" i="0">
                 <a:solidFill>
-                  <a:srgbClr val="0099CC"/>
+                  <a:srgbClr val="FFFFFF"/>
                 </a:solidFill>
                 <a:latin typeface="Calibri"/>
               </a:rPr>
@@ -7256,7 +6832,7 @@
             <a:r>
               <a:rPr sz="1600" b="0" i="0">
                 <a:solidFill>
-                  <a:srgbClr val="0099CC"/>
+                  <a:srgbClr val="5AC8F0"/>
                 </a:solidFill>
                 <a:latin typeface="Calibri"/>
               </a:rPr>
@@ -7483,7 +7059,7 @@
             <a:r>
               <a:rPr sz="1100" b="0" i="0">
                 <a:solidFill>
-                  <a:srgbClr val="A0C8F0"/>
+                  <a:srgbClr val="3A454D"/>
                 </a:solidFill>
                 <a:latin typeface="Calibri"/>
               </a:rPr>

</xml_diff>

<commit_message>
fix(slides): docentes por clase segun programa CFP oficial + PDFs regenerados
</commit_message>
<xml_diff>
--- a/clase_01_estrategia_transformacion/slides/slides_clase01_avanzado.pptx
+++ b/clase_01_estrategia_transformacion/slides/slides_clase01_avanzado.pptx
@@ -3243,13 +3243,13 @@
           <a:lstStyle/>
           <a:p>
             <a:r>
-              <a:rPr sz="1350" b="1">
+              <a:rPr sz="1250" b="1">
                 <a:solidFill>
                   <a:srgbClr val="FFFFFF"/>
                 </a:solidFill>
                 <a:latin typeface="Segoe UI"/>
               </a:rPr>
-              <a:t>Docentes: Ariel Giamportone, Soraya Corvalán</a:t>
+              <a:t>Docentes: Ariel Giamportone, Soraya Corvalán, María Ana Reussi, Soledad Gurisich</a:t>
             </a:r>
           </a:p>
         </p:txBody>

</xml_diff>

<commit_message>
fix(slides): logo oficial PesquerosEnIA en portadas de los 15 decks + PDFs regenerados
</commit_message>
<xml_diff>
--- a/clase_01_estrategia_transformacion/slides/slides_clase01_avanzado.pptx
+++ b/clase_01_estrategia_transformacion/slides/slides_clase01_avanzado.pptx
@@ -3096,14 +3096,14 @@
       <p:grpSpPr/>
       <p:pic>
         <p:nvPicPr>
-          <p:cNvPr id="2" name="Picture 1" descr="cover_bg.png"/>
+          <p:cNvPr id="8" name="Picture 7" descr="cover_bg.png"/>
           <p:cNvPicPr>
             <a:picLocks noChangeAspect="1"/>
           </p:cNvPicPr>
           <p:nvPr/>
         </p:nvPicPr>
         <p:blipFill>
-          <a:blip r:embed="rId5"/>
+          <a:blip r:embed="rId6"/>
           <a:stretch>
             <a:fillRect/>
           </a:stretch>

</xml_diff>